<commit_message>
chore: migrate to Bun, Hardhat v3 ESM, React 19 and Tailwind 4
Replace npm lockfiles with bun.lock and switch scripts, Dockerfiles, and CI to Bun 1.4. Port Hardhat config, deploy scripts, and contract tests to ESM with hardhat-toolbox-mocha-ethers v3. Upgrade frontend to React 19, react-router 7, Tailwind 4 with .cjs configs. Sanitize Etherscan/JWT/Mongo placeholders in docs and config, ignore generated types/, and add Review 2 report deliverables.
</commit_message>
<xml_diff>
--- a/docs/reviews/Review 2/Review 2.pptx
+++ b/docs/reviews/Review 2/Review 2.pptx
@@ -3795,8 +3795,8 @@
         </p:nvSpPr>
         <p:spPr>
           <a:xfrm>
-            <a:off x="1907459" y="1906442"/>
-            <a:ext cx="8924544" cy="1255728"/>
+            <a:off x="1912597" y="1730073"/>
+            <a:ext cx="8924544" cy="1698927"/>
           </a:xfrm>
           <a:prstGeom prst="rect">
             <a:avLst/>
@@ -3817,24 +3817,30 @@
               <a:t>B.Tech BCSE497J – Project 1</a:t>
             </a:r>
             <a:br>
+              <a:rPr lang="en-IN" sz="2000" b="1" dirty="0">
+                <a:latin typeface="Times New Roman" panose="02020603050405020304" pitchFamily="18" charset="0"/>
+                <a:cs typeface="Times New Roman" panose="02020603050405020304" pitchFamily="18" charset="0"/>
+              </a:rPr>
+            </a:br>
+            <a:br>
               <a:rPr lang="en-IN" sz="3200" b="1" dirty="0">
                 <a:latin typeface="Times New Roman" panose="02020603050405020304" pitchFamily="18" charset="0"/>
                 <a:cs typeface="Times New Roman" panose="02020603050405020304" pitchFamily="18" charset="0"/>
               </a:rPr>
             </a:br>
             <a:r>
-              <a:rPr lang="en-US" sz="3200" b="1" dirty="0" err="1">
-                <a:latin typeface="Times New Roman" panose="02020603050405020304" pitchFamily="18" charset="0"/>
-                <a:cs typeface="Times New Roman" panose="02020603050405020304" pitchFamily="18" charset="0"/>
-              </a:rPr>
-              <a:t>CareChain</a:t>
-            </a:r>
-            <a:r>
               <a:rPr lang="en-US" sz="3200" b="1" dirty="0">
                 <a:latin typeface="Times New Roman" panose="02020603050405020304" pitchFamily="18" charset="0"/>
                 <a:cs typeface="Times New Roman" panose="02020603050405020304" pitchFamily="18" charset="0"/>
               </a:rPr>
-              <a:t>: Decentralized Electronic Health Record Management</a:t>
+              <a:t>CareChain: Decentralized Electronic Health Record </a:t>
+            </a:r>
+            <a:r>
+              <a:rPr lang="en-US" sz="3200" b="1">
+                <a:latin typeface="Times New Roman" panose="02020603050405020304" pitchFamily="18" charset="0"/>
+                <a:cs typeface="Times New Roman" panose="02020603050405020304" pitchFamily="18" charset="0"/>
+              </a:rPr>
+              <a:t>Management System</a:t>
             </a:r>
             <a:endParaRPr lang="en-IN" sz="3200" b="1" dirty="0">
               <a:latin typeface="Times New Roman" panose="02020603050405020304" pitchFamily="18" charset="0"/>
@@ -3857,7 +3863,7 @@
         </p:nvSpPr>
         <p:spPr>
           <a:xfrm>
-            <a:off x="2609088" y="3208471"/>
+            <a:off x="2609088" y="3645123"/>
             <a:ext cx="7071360" cy="2426305"/>
           </a:xfrm>
           <a:prstGeom prst="rect">
@@ -3908,7 +3914,7 @@
                 <a:latin typeface="Times New Roman"/>
                 <a:cs typeface="Times New Roman"/>
               </a:rPr>
-              <a:t>members:</a:t>
+              <a:t>member:</a:t>
             </a:r>
             <a:endParaRPr sz="2000" dirty="0">
               <a:latin typeface="Times New Roman"/>
@@ -4126,7 +4132,7 @@
                 <a:latin typeface="Times New Roman" panose="02020603050405020304" pitchFamily="18" charset="0"/>
                 <a:cs typeface="Times New Roman" panose="02020603050405020304" pitchFamily="18" charset="0"/>
               </a:rPr>
-              <a:t>• Successfully engineered and demonstrated a working hybrid decentralized EHR management platform.</a:t>
+              <a:t>Successfully engineered and demonstrated a working hybrid decentralized EHR management platform.</a:t>
             </a:r>
           </a:p>
           <a:p>
@@ -4155,12 +4161,6 @@
               </a:rPr>
               <a:t>Achieved sub-second cryptographic encryption and cost-effective smart contract execution.</a:t>
             </a:r>
-          </a:p>
-          <a:p>
-            <a:endParaRPr lang="en-IN" dirty="0">
-              <a:latin typeface="Times New Roman" panose="02020603050405020304" pitchFamily="18" charset="0"/>
-              <a:cs typeface="Times New Roman" panose="02020603050405020304" pitchFamily="18" charset="0"/>
-            </a:endParaRPr>
           </a:p>
         </p:txBody>
       </p:sp>
@@ -5099,22 +5099,25 @@
           <a:lstStyle/>
           <a:p>
             <a:r>
-              <a:rPr lang="en-US" dirty="0"/>
+              <a:rPr lang="en-US" sz="2400" dirty="0"/>
               <a:t>Centralized hospital EHR databases represent lucrative single points of failure vulnerable to ransomware, unauthorized commercial data exploitation, and catastrophic breaches (over 133M records exposed globally). Patients lack direct sovereignty and real-time auditing over who accesses or shares their sensitive diagnostic history.</a:t>
             </a:r>
           </a:p>
           <a:p>
-            <a:r>
-              <a:rPr lang="en-IN" dirty="0" err="1"/>
+            <a:endParaRPr lang="en-US" sz="2400" dirty="0"/>
+          </a:p>
+          <a:p>
+            <a:r>
+              <a:rPr lang="en-IN" sz="2400" dirty="0" err="1"/>
               <a:t>CareChain</a:t>
             </a:r>
             <a:r>
-              <a:rPr lang="en-IN" dirty="0"/>
+              <a:rPr lang="en-IN" sz="2400" dirty="0"/>
               <a:t> introduces a zero-trust, hybrid architecture combining client-side AES-256-GCM encryption, decentralized IPFS pinning, and Ethereum/Polygon smart contracts. The platform ensures zero Protected Health Information (PHI) is ever exposed on-chain while providing non-repudiable access logs.</a:t>
             </a:r>
           </a:p>
           <a:p>
-            <a:endParaRPr lang="en-IN" dirty="0">
+            <a:endParaRPr lang="en-IN" sz="2400" dirty="0">
               <a:latin typeface="Times New Roman" panose="02020603050405020304" pitchFamily="18" charset="0"/>
               <a:cs typeface="Times New Roman" panose="02020603050405020304" pitchFamily="18" charset="0"/>
             </a:endParaRPr>
@@ -5139,7 +5142,7 @@
         </p:nvSpPr>
         <p:spPr>
           <a:xfrm>
-            <a:off x="838200" y="739558"/>
+            <a:off x="673814" y="729284"/>
             <a:ext cx="10515600" cy="576696"/>
           </a:xfrm>
           <a:prstGeom prst="rect">
@@ -5320,73 +5323,43 @@
           <a:lstStyle/>
           <a:p>
             <a:r>
-              <a:rPr lang="en-US" dirty="0">
+              <a:rPr lang="en-US" sz="2400" dirty="0">
                 <a:latin typeface="Times New Roman" panose="02020603050405020304" pitchFamily="18" charset="0"/>
                 <a:cs typeface="Times New Roman" panose="02020603050405020304" pitchFamily="18" charset="0"/>
               </a:rPr>
-              <a:t>Existing systems rely on centralized cloud repositories vulnerable to single-point breaches. </a:t>
-            </a:r>
-            <a:r>
-              <a:rPr lang="en-US" dirty="0" err="1">
+              <a:t>Existing systems rely on centralized cloud repositories vulnerable to single-point breaches. CareChain decouples storage to IPFS with 46-byte cryptographic CID references.</a:t>
+            </a:r>
+          </a:p>
+          <a:p>
+            <a:endParaRPr lang="en-US" sz="2400" dirty="0">
+              <a:latin typeface="Times New Roman" panose="02020603050405020304" pitchFamily="18" charset="0"/>
+              <a:cs typeface="Times New Roman" panose="02020603050405020304" pitchFamily="18" charset="0"/>
+            </a:endParaRPr>
+          </a:p>
+          <a:p>
+            <a:r>
+              <a:rPr lang="en-US" sz="2400" dirty="0">
                 <a:latin typeface="Times New Roman" panose="02020603050405020304" pitchFamily="18" charset="0"/>
                 <a:cs typeface="Times New Roman" panose="02020603050405020304" pitchFamily="18" charset="0"/>
               </a:rPr>
-              <a:t>CareChain</a:t>
-            </a:r>
-            <a:r>
-              <a:rPr lang="en-US" dirty="0">
+              <a:t>Storing large medical files directly on-chain is economically unfeasible. CareChain stores encrypted payloads off-chain, ensuring O(1) constant gas consumption.</a:t>
+            </a:r>
+          </a:p>
+          <a:p>
+            <a:endParaRPr lang="en-US" sz="2400" dirty="0">
+              <a:latin typeface="Times New Roman" panose="02020603050405020304" pitchFamily="18" charset="0"/>
+              <a:cs typeface="Times New Roman" panose="02020603050405020304" pitchFamily="18" charset="0"/>
+            </a:endParaRPr>
+          </a:p>
+          <a:p>
+            <a:r>
+              <a:rPr lang="en-US" sz="2400" dirty="0">
                 <a:latin typeface="Times New Roman" panose="02020603050405020304" pitchFamily="18" charset="0"/>
                 <a:cs typeface="Times New Roman" panose="02020603050405020304" pitchFamily="18" charset="0"/>
               </a:rPr>
-              <a:t> decouples storage to IPFS with 46-byte cryptographic CID references.</a:t>
-            </a:r>
-          </a:p>
-          <a:p>
-            <a:r>
-              <a:rPr lang="en-US" dirty="0">
-                <a:latin typeface="Times New Roman" panose="02020603050405020304" pitchFamily="18" charset="0"/>
-                <a:cs typeface="Times New Roman" panose="02020603050405020304" pitchFamily="18" charset="0"/>
-              </a:rPr>
-              <a:t>Storing large medical files directly on-chain is economically unfeasible. </a:t>
-            </a:r>
-            <a:r>
-              <a:rPr lang="en-US" dirty="0" err="1">
-                <a:latin typeface="Times New Roman" panose="02020603050405020304" pitchFamily="18" charset="0"/>
-                <a:cs typeface="Times New Roman" panose="02020603050405020304" pitchFamily="18" charset="0"/>
-              </a:rPr>
-              <a:t>CareChain</a:t>
-            </a:r>
-            <a:r>
-              <a:rPr lang="en-US" dirty="0">
-                <a:latin typeface="Times New Roman" panose="02020603050405020304" pitchFamily="18" charset="0"/>
-                <a:cs typeface="Times New Roman" panose="02020603050405020304" pitchFamily="18" charset="0"/>
-              </a:rPr>
-              <a:t> stores encrypted payloads off-chain, ensuring O(1) constant gas consumption.</a:t>
-            </a:r>
-          </a:p>
-          <a:p>
-            <a:r>
-              <a:rPr lang="en-US" dirty="0">
-                <a:latin typeface="Times New Roman" panose="02020603050405020304" pitchFamily="18" charset="0"/>
-                <a:cs typeface="Times New Roman" panose="02020603050405020304" pitchFamily="18" charset="0"/>
-              </a:rPr>
-              <a:t>Traditional EHRs prevent patients from dynamically granting/revoking doctor access. </a:t>
-            </a:r>
-            <a:r>
-              <a:rPr lang="en-US" dirty="0" err="1">
-                <a:latin typeface="Times New Roman" panose="02020603050405020304" pitchFamily="18" charset="0"/>
-                <a:cs typeface="Times New Roman" panose="02020603050405020304" pitchFamily="18" charset="0"/>
-              </a:rPr>
-              <a:t>CareChain</a:t>
-            </a:r>
-            <a:r>
-              <a:rPr lang="en-US" dirty="0">
-                <a:latin typeface="Times New Roman" panose="02020603050405020304" pitchFamily="18" charset="0"/>
-                <a:cs typeface="Times New Roman" panose="02020603050405020304" pitchFamily="18" charset="0"/>
-              </a:rPr>
-              <a:t> smart contracts execute instant on-chain permission updates.</a:t>
-            </a:r>
-            <a:endParaRPr lang="en-IN" dirty="0">
+              <a:t>Traditional EHRs prevent patients from dynamically granting/revoking doctor access. CareChain smart contracts execute instant on-chain permission updates.</a:t>
+            </a:r>
+            <a:endParaRPr lang="en-IN" sz="2400" dirty="0">
               <a:latin typeface="Times New Roman" panose="02020603050405020304" pitchFamily="18" charset="0"/>
               <a:cs typeface="Times New Roman" panose="02020603050405020304" pitchFamily="18" charset="0"/>
             </a:endParaRPr>
@@ -5810,7 +5783,7 @@
         </p:nvSpPr>
         <p:spPr>
           <a:xfrm>
-            <a:off x="460248" y="4413148"/>
+            <a:off x="460248" y="3238073"/>
             <a:ext cx="11523407" cy="646331"/>
           </a:xfrm>
           <a:prstGeom prst="rect">
@@ -5836,19 +5809,8 @@
                 <a:latin typeface="Times New Roman" panose="02020603050405020304" pitchFamily="18" charset="0"/>
                 <a:cs typeface="Times New Roman" panose="02020603050405020304" pitchFamily="18" charset="0"/>
               </a:rPr>
-              <a:t>Outcomes: Open Source Application</a:t>
-            </a:r>
-            <a:r>
-              <a:rPr lang="en-US" sz="1600" dirty="0">
-                <a:latin typeface="Times New Roman" panose="02020603050405020304" pitchFamily="18" charset="0"/>
-                <a:cs typeface="Times New Roman" panose="02020603050405020304" pitchFamily="18" charset="0"/>
-              </a:rPr>
-              <a:t>}</a:t>
-            </a:r>
-            <a:endParaRPr lang="en-IN" sz="1600" dirty="0">
-              <a:latin typeface="Times New Roman" panose="02020603050405020304" pitchFamily="18" charset="0"/>
-              <a:cs typeface="Times New Roman" panose="02020603050405020304" pitchFamily="18" charset="0"/>
-            </a:endParaRPr>
+              <a:t>Outcome: Open Source Application</a:t>
+            </a:r>
           </a:p>
           <a:p>
             <a:endParaRPr lang="en-IN" dirty="0">
@@ -5932,7 +5894,7 @@
         </p:nvSpPr>
         <p:spPr>
           <a:xfrm>
-            <a:off x="365914" y="3164440"/>
+            <a:off x="516396" y="3589913"/>
             <a:ext cx="4514311" cy="954107"/>
           </a:xfrm>
           <a:prstGeom prst="rect">
@@ -5974,7 +5936,7 @@
         </p:nvSpPr>
         <p:spPr>
           <a:xfrm>
-            <a:off x="5400037" y="3390157"/>
+            <a:off x="5499535" y="3299628"/>
             <a:ext cx="2122042" cy="523220"/>
           </a:xfrm>
           <a:prstGeom prst="rect">

</xml_diff>